<commit_message>
Update marketing deck and site with real FleetCo branding.
Use (360) 952-1249, live pricing ($299/$599/$999), and leadership names across PowerPoint, site config, and contact page.
</commit_message>
<xml_diff>
--- a/marketing/FleetCo-Client-Presentation.pptx
+++ b/marketing/FleetCo-Client-Presentation.pptx
@@ -1660,29 +1660,29 @@
         </p:nvSpPr>
         <p:spPr>
           <a:xfrm>
-            <a:off x="640080" y="3931920"/>
-            <a:ext cx="7315200" cy="457200"/>
-          </a:xfrm>
-          <a:prstGeom prst="rect">
-            <a:avLst/>
-          </a:prstGeom>
-          <a:noFill/>
-          <a:ln/>
-        </p:spPr>
-        <p:txBody>
-          <a:bodyPr wrap="square" rtlCol="0" anchor="ctr"/>
-          <a:lstStyle/>
-          <a:p>
-            <a:pPr indent="0" marL="0">
-              <a:buNone/>
-            </a:pPr>
-            <a:r>
-              <a:rPr lang="en-US" sz="1600" dirty="0">
+            <a:off x="640080" y="3794760"/>
+            <a:ext cx="7315200" cy="411480"/>
+          </a:xfrm>
+          <a:prstGeom prst="rect">
+            <a:avLst/>
+          </a:prstGeom>
+          <a:noFill/>
+          <a:ln/>
+        </p:spPr>
+        <p:txBody>
+          <a:bodyPr wrap="square" rtlCol="0" anchor="ctr"/>
+          <a:lstStyle/>
+          <a:p>
+            <a:pPr indent="0" marL="0">
+              <a:buNone/>
+            </a:pPr>
+            <a:r>
+              <a:rPr lang="en-US" sz="1600" i="1" dirty="0">
                 <a:solidFill>
                   <a:srgbClr val="64748B"/>
                 </a:solidFill>
               </a:rPr>
-              <a:t>Built for owner-operators &amp; small fleets</a:t>
+              <a:t>Move freight. We handle the rest.</a:t>
             </a:r>
             <a:endParaRPr lang="en-US" sz="1600" dirty="0"/>
           </a:p>
@@ -1696,7 +1696,7 @@
         </p:nvSpPr>
         <p:spPr>
           <a:xfrm>
-            <a:off x="640080" y="4572000"/>
+            <a:off x="640080" y="4251960"/>
             <a:ext cx="7315200" cy="365760"/>
           </a:xfrm>
           <a:prstGeom prst="rect">
@@ -1713,12 +1713,48 @@
               <a:buNone/>
             </a:pPr>
             <a:r>
+              <a:rPr lang="en-US" sz="1400" dirty="0">
+                <a:solidFill>
+                  <a:srgbClr val="64748B"/>
+                </a:solidFill>
+              </a:rPr>
+              <a:t>Built for owner-operators &amp; small fleets · Dallas, TX</a:t>
+            </a:r>
+            <a:endParaRPr lang="en-US" sz="1400" dirty="0"/>
+          </a:p>
+        </p:txBody>
+      </p:sp>
+      <p:sp>
+        <p:nvSpPr>
+          <p:cNvPr id="8" name="Text 6"/>
+          <p:cNvSpPr/>
+          <p:nvPr/>
+        </p:nvSpPr>
+        <p:spPr>
+          <a:xfrm>
+            <a:off x="640080" y="4709160"/>
+            <a:ext cx="7315200" cy="365760"/>
+          </a:xfrm>
+          <a:prstGeom prst="rect">
+            <a:avLst/>
+          </a:prstGeom>
+          <a:noFill/>
+          <a:ln/>
+        </p:spPr>
+        <p:txBody>
+          <a:bodyPr wrap="square" rtlCol="0" anchor="ctr"/>
+          <a:lstStyle/>
+          <a:p>
+            <a:pPr indent="0" marL="0">
+              <a:buNone/>
+            </a:pPr>
+            <a:r>
               <a:rPr lang="en-US" sz="1400" b="1" dirty="0">
                 <a:solidFill>
                   <a:srgbClr val="F59E0B"/>
                 </a:solidFill>
               </a:rPr>
-              <a:t>fleetcomanagement.org  ·  (214) 555-0198  ·  Dallas, TX</a:t>
+              <a:t>fleetcomanagement.org  ·  (360) 952-1249</a:t>
             </a:r>
             <a:endParaRPr lang="en-US" sz="1400" dirty="0"/>
           </a:p>
@@ -1726,7 +1762,7 @@
       </p:sp>
       <p:sp>
         <p:nvSpPr>
-          <p:cNvPr id="8" name="Text 6"/>
+          <p:cNvPr id="9" name="Text 7"/>
           <p:cNvSpPr/>
           <p:nvPr/>
         </p:nvSpPr>
@@ -2290,7 +2326,7 @@
                   <a:srgbClr val="64748B"/>
                 </a:solidFill>
               </a:rPr>
-              <a:t>Fleetco Management LLC  ·  fleetcomanagement.org  ·  Dallas, TX</a:t>
+              <a:t>Fleetco Management LLC  ·  fleetcomanagement.org  ·  (360) 952-1249  ·  Dallas, TX</a:t>
             </a:r>
             <a:endParaRPr lang="en-US" sz="900" dirty="0"/>
           </a:p>
@@ -3060,7 +3096,7 @@
                   <a:srgbClr val="64748B"/>
                 </a:solidFill>
               </a:rPr>
-              <a:t>Fleetco Management LLC  ·  fleetcomanagement.org  ·  Dallas, TX</a:t>
+              <a:t>Fleetco Management LLC  ·  fleetcomanagement.org  ·  (360) 952-1249  ·  Dallas, TX</a:t>
             </a:r>
             <a:endParaRPr lang="en-US" sz="900" dirty="0"/>
           </a:p>
@@ -3405,7 +3441,7 @@
                   <a:srgbClr val="F59E0B"/>
                 </a:solidFill>
               </a:rPr>
-              <a:t>Demo live at fleetcomanagement.org/login  ·  admin@fleetco.com</a:t>
+              <a:t>Live demo: https://fleetcomanagement.org/login</a:t>
             </a:r>
             <a:endParaRPr lang="en-US" sz="1300" dirty="0"/>
           </a:p>
@@ -3441,7 +3477,7 @@
                   <a:srgbClr val="64748B"/>
                 </a:solidFill>
               </a:rPr>
-              <a:t>4 customers · 12 units · 8 work orders · 5 active loads — pre-loaded demo data</a:t>
+              <a:t>4 customers · 12 units · 8 work orders · 5 loads — pre-loaded demo data</a:t>
             </a:r>
             <a:endParaRPr lang="en-US" sz="1100" dirty="0"/>
           </a:p>
@@ -4121,7 +4157,7 @@
                   <a:srgbClr val="64748B"/>
                 </a:solidFill>
               </a:rPr>
-              <a:t>Fleetco Management LLC  ·  fleetcomanagement.org  ·  Dallas, TX</a:t>
+              <a:t>Fleetco Management LLC  ·  fleetcomanagement.org  ·  (360) 952-1249  ·  Dallas, TX</a:t>
             </a:r>
             <a:endParaRPr lang="en-US" sz="900" dirty="0"/>
           </a:p>
@@ -4449,7 +4485,7 @@
                   <a:srgbClr val="FFFFFF"/>
                 </a:solidFill>
               </a:rPr>
-              <a:t>6–50 units</a:t>
+              <a:t>6–15 units</a:t>
             </a:r>
             <a:endParaRPr lang="en-US" sz="1200" dirty="0"/>
           </a:p>
@@ -4543,7 +4579,7 @@
                   <a:srgbClr val="F59E0B"/>
                 </a:solidFill>
               </a:rPr>
-              <a:t>Fleet Managers</a:t>
+              <a:t>Established Fleets</a:t>
             </a:r>
             <a:endParaRPr lang="en-US" sz="1400" dirty="0"/>
           </a:p>
@@ -4579,7 +4615,7 @@
                   <a:srgbClr val="FFFFFF"/>
                 </a:solidFill>
               </a:rPr>
-              <a:t>Multi-customer</a:t>
+              <a:t>16+ units</a:t>
             </a:r>
             <a:endParaRPr lang="en-US" sz="1200" dirty="0"/>
           </a:p>
@@ -4615,7 +4651,7 @@
                   <a:srgbClr val="64748B"/>
                 </a:solidFill>
               </a:rPr>
-              <a:t>Client portal, P&amp;L, executive dashboards</a:t>
+              <a:t>Full-service management &amp; dedicated support</a:t>
             </a:r>
             <a:endParaRPr lang="en-US" sz="1100" dirty="0"/>
           </a:p>
@@ -4651,7 +4687,7 @@
                   <a:srgbClr val="64748B"/>
                 </a:solidFill>
               </a:rPr>
-              <a:t>Fleetco Management LLC  ·  fleetcomanagement.org  ·  Dallas, TX</a:t>
+              <a:t>Fleetco Management LLC  ·  fleetcomanagement.org  ·  (360) 952-1249  ·  Dallas, TX</a:t>
             </a:r>
             <a:endParaRPr lang="en-US" sz="900" dirty="0"/>
           </a:p>
@@ -4719,7 +4755,7 @@
                   <a:srgbClr val="F59E0B"/>
                 </a:solidFill>
               </a:rPr>
-              <a:t>GET STARTED</a:t>
+              <a:t>PLANS &amp; PRICING</a:t>
             </a:r>
             <a:endParaRPr lang="en-US" sz="1100" dirty="0"/>
           </a:p>
@@ -4770,11 +4806,11 @@
         <p:spPr>
           <a:xfrm>
             <a:off x="548640" y="1554480"/>
-            <a:ext cx="2697480" cy="2286000"/>
+            <a:ext cx="2697480" cy="2606040"/>
           </a:xfrm>
           <a:prstGeom prst="roundRect">
             <a:avLst>
-              <a:gd name="adj" fmla="val 3200"/>
+              <a:gd name="adj" fmla="val 2807"/>
             </a:avLst>
           </a:prstGeom>
           <a:solidFill>
@@ -4832,7 +4868,7 @@
         </p:nvSpPr>
         <p:spPr>
           <a:xfrm>
-            <a:off x="685800" y="2148840"/>
+            <a:off x="685800" y="2103120"/>
             <a:ext cx="2468880" cy="457200"/>
           </a:xfrm>
           <a:prstGeom prst="rect">
@@ -4854,7 +4890,7 @@
                   <a:srgbClr val="F59E0B"/>
                 </a:solidFill>
               </a:rPr>
-              <a:t>$99/mo</a:t>
+              <a:t>$299/mo</a:t>
             </a:r>
             <a:endParaRPr lang="en-US" sz="2000" dirty="0"/>
           </a:p>
@@ -4868,8 +4904,44 @@
         </p:nvSpPr>
         <p:spPr>
           <a:xfrm>
-            <a:off x="685800" y="2697480"/>
-            <a:ext cx="2468880" cy="822960"/>
+            <a:off x="685800" y="2606040"/>
+            <a:ext cx="2468880" cy="274320"/>
+          </a:xfrm>
+          <a:prstGeom prst="rect">
+            <a:avLst/>
+          </a:prstGeom>
+          <a:noFill/>
+          <a:ln/>
+        </p:spPr>
+        <p:txBody>
+          <a:bodyPr wrap="square" rtlCol="0" anchor="ctr"/>
+          <a:lstStyle/>
+          <a:p>
+            <a:pPr indent="0" marL="0">
+              <a:buNone/>
+            </a:pPr>
+            <a:r>
+              <a:rPr lang="en-US" sz="1100" b="1" dirty="0">
+                <a:solidFill>
+                  <a:srgbClr val="0F172A"/>
+                </a:solidFill>
+              </a:rPr>
+              <a:t>1–5 vehicles</a:t>
+            </a:r>
+            <a:endParaRPr lang="en-US" sz="1100" dirty="0"/>
+          </a:p>
+        </p:txBody>
+      </p:sp>
+      <p:sp>
+        <p:nvSpPr>
+          <p:cNvPr id="8" name="Text 6"/>
+          <p:cNvSpPr/>
+          <p:nvPr/>
+        </p:nvSpPr>
+        <p:spPr>
+          <a:xfrm>
+            <a:off x="685800" y="2926080"/>
+            <a:ext cx="2468880" cy="1005840"/>
           </a:xfrm>
           <a:prstGeom prst="rect">
             <a:avLst/>
@@ -4890,7 +4962,7 @@
                   <a:srgbClr val="64748B"/>
                 </a:solidFill>
               </a:rPr>
-              <a:t>Up to 5 units · Core portal &amp; compliance</a:t>
+              <a:t>Fleet manager · parts sourcing · fuel optimization · monthly reports</a:t>
             </a:r>
             <a:endParaRPr lang="en-US" sz="1000" dirty="0"/>
           </a:p>
@@ -4898,18 +4970,18 @@
       </p:sp>
       <p:sp>
         <p:nvSpPr>
-          <p:cNvPr id="8" name="Shape 6"/>
+          <p:cNvPr id="9" name="Shape 7"/>
           <p:cNvSpPr/>
           <p:nvPr/>
         </p:nvSpPr>
         <p:spPr>
           <a:xfrm>
             <a:off x="3429000" y="1554480"/>
-            <a:ext cx="2697480" cy="2286000"/>
+            <a:ext cx="2697480" cy="2606040"/>
           </a:xfrm>
           <a:prstGeom prst="roundRect">
             <a:avLst>
-              <a:gd name="adj" fmla="val 3200"/>
+              <a:gd name="adj" fmla="val 2807"/>
             </a:avLst>
           </a:prstGeom>
           <a:solidFill>
@@ -4925,7 +4997,7 @@
       </p:sp>
       <p:sp>
         <p:nvSpPr>
-          <p:cNvPr id="9" name="Text 7"/>
+          <p:cNvPr id="10" name="Text 8"/>
           <p:cNvSpPr/>
           <p:nvPr/>
         </p:nvSpPr>
@@ -4961,13 +5033,13 @@
       </p:sp>
       <p:sp>
         <p:nvSpPr>
-          <p:cNvPr id="10" name="Text 8"/>
-          <p:cNvSpPr/>
-          <p:nvPr/>
-        </p:nvSpPr>
-        <p:spPr>
-          <a:xfrm>
-            <a:off x="3566160" y="2148840"/>
+          <p:cNvPr id="11" name="Text 9"/>
+          <p:cNvSpPr/>
+          <p:nvPr/>
+        </p:nvSpPr>
+        <p:spPr>
+          <a:xfrm>
+            <a:off x="3566160" y="2103120"/>
             <a:ext cx="2468880" cy="457200"/>
           </a:xfrm>
           <a:prstGeom prst="rect">
@@ -4989,7 +5061,7 @@
                   <a:srgbClr val="F59E0B"/>
                 </a:solidFill>
               </a:rPr>
-              <a:t>$249/mo</a:t>
+              <a:t>$599/mo</a:t>
             </a:r>
             <a:endParaRPr lang="en-US" sz="2000" dirty="0"/>
           </a:p>
@@ -4997,14 +5069,50 @@
       </p:sp>
       <p:sp>
         <p:nvSpPr>
-          <p:cNvPr id="11" name="Text 9"/>
-          <p:cNvSpPr/>
-          <p:nvPr/>
-        </p:nvSpPr>
-        <p:spPr>
-          <a:xfrm>
-            <a:off x="3566160" y="2697480"/>
-            <a:ext cx="2468880" cy="822960"/>
+          <p:cNvPr id="12" name="Text 10"/>
+          <p:cNvSpPr/>
+          <p:nvPr/>
+        </p:nvSpPr>
+        <p:spPr>
+          <a:xfrm>
+            <a:off x="3566160" y="2606040"/>
+            <a:ext cx="2468880" cy="274320"/>
+          </a:xfrm>
+          <a:prstGeom prst="rect">
+            <a:avLst/>
+          </a:prstGeom>
+          <a:noFill/>
+          <a:ln/>
+        </p:spPr>
+        <p:txBody>
+          <a:bodyPr wrap="square" rtlCol="0" anchor="ctr"/>
+          <a:lstStyle/>
+          <a:p>
+            <a:pPr indent="0" marL="0">
+              <a:buNone/>
+            </a:pPr>
+            <a:r>
+              <a:rPr lang="en-US" sz="1100" b="1" dirty="0">
+                <a:solidFill>
+                  <a:srgbClr val="0F172A"/>
+                </a:solidFill>
+              </a:rPr>
+              <a:t>6–15 vehicles</a:t>
+            </a:r>
+            <a:endParaRPr lang="en-US" sz="1100" dirty="0"/>
+          </a:p>
+        </p:txBody>
+      </p:sp>
+      <p:sp>
+        <p:nvSpPr>
+          <p:cNvPr id="13" name="Text 11"/>
+          <p:cNvSpPr/>
+          <p:nvPr/>
+        </p:nvSpPr>
+        <p:spPr>
+          <a:xfrm>
+            <a:off x="3566160" y="2926080"/>
+            <a:ext cx="2468880" cy="1005840"/>
           </a:xfrm>
           <a:prstGeom prst="rect">
             <a:avLst/>
@@ -5025,7 +5133,7 @@
                   <a:srgbClr val="64748B"/>
                 </a:solidFill>
               </a:rPr>
-              <a:t>Up to 25 units · Full ops + fuel + analytics</a:t>
+              <a:t>Everything in Starter · PM scheduling · priority support · budget reviews</a:t>
             </a:r>
             <a:endParaRPr lang="en-US" sz="1000" dirty="0"/>
           </a:p>
@@ -5033,18 +5141,18 @@
       </p:sp>
       <p:sp>
         <p:nvSpPr>
-          <p:cNvPr id="12" name="Shape 10"/>
+          <p:cNvPr id="14" name="Shape 12"/>
           <p:cNvSpPr/>
           <p:nvPr/>
         </p:nvSpPr>
         <p:spPr>
           <a:xfrm>
             <a:off x="6309360" y="1554480"/>
-            <a:ext cx="2697480" cy="2286000"/>
+            <a:ext cx="2697480" cy="2606040"/>
           </a:xfrm>
           <a:prstGeom prst="roundRect">
             <a:avLst>
-              <a:gd name="adj" fmla="val 3200"/>
+              <a:gd name="adj" fmla="val 2807"/>
             </a:avLst>
           </a:prstGeom>
           <a:solidFill>
@@ -5060,7 +5168,7 @@
       </p:sp>
       <p:sp>
         <p:nvSpPr>
-          <p:cNvPr id="13" name="Text 11"/>
+          <p:cNvPr id="15" name="Text 13"/>
           <p:cNvSpPr/>
           <p:nvPr/>
         </p:nvSpPr>
@@ -5096,13 +5204,13 @@
       </p:sp>
       <p:sp>
         <p:nvSpPr>
-          <p:cNvPr id="14" name="Text 12"/>
-          <p:cNvSpPr/>
-          <p:nvPr/>
-        </p:nvSpPr>
-        <p:spPr>
-          <a:xfrm>
-            <a:off x="6446520" y="2148840"/>
+          <p:cNvPr id="16" name="Text 14"/>
+          <p:cNvSpPr/>
+          <p:nvPr/>
+        </p:nvSpPr>
+        <p:spPr>
+          <a:xfrm>
+            <a:off x="6446520" y="2103120"/>
             <a:ext cx="2468880" cy="457200"/>
           </a:xfrm>
           <a:prstGeom prst="rect">
@@ -5124,7 +5232,7 @@
                   <a:srgbClr val="F59E0B"/>
                 </a:solidFill>
               </a:rPr>
-              <a:t>Custom</a:t>
+              <a:t>$999/mo</a:t>
             </a:r>
             <a:endParaRPr lang="en-US" sz="2000" dirty="0"/>
           </a:p>
@@ -5132,14 +5240,50 @@
       </p:sp>
       <p:sp>
         <p:nvSpPr>
-          <p:cNvPr id="15" name="Text 13"/>
-          <p:cNvSpPr/>
-          <p:nvPr/>
-        </p:nvSpPr>
-        <p:spPr>
-          <a:xfrm>
-            <a:off x="6446520" y="2697480"/>
-            <a:ext cx="2468880" cy="822960"/>
+          <p:cNvPr id="17" name="Text 15"/>
+          <p:cNvSpPr/>
+          <p:nvPr/>
+        </p:nvSpPr>
+        <p:spPr>
+          <a:xfrm>
+            <a:off x="6446520" y="2606040"/>
+            <a:ext cx="2468880" cy="274320"/>
+          </a:xfrm>
+          <a:prstGeom prst="rect">
+            <a:avLst/>
+          </a:prstGeom>
+          <a:noFill/>
+          <a:ln/>
+        </p:spPr>
+        <p:txBody>
+          <a:bodyPr wrap="square" rtlCol="0" anchor="ctr"/>
+          <a:lstStyle/>
+          <a:p>
+            <a:pPr indent="0" marL="0">
+              <a:buNone/>
+            </a:pPr>
+            <a:r>
+              <a:rPr lang="en-US" sz="1100" b="1" dirty="0">
+                <a:solidFill>
+                  <a:srgbClr val="0F172A"/>
+                </a:solidFill>
+              </a:rPr>
+              <a:t>16+ vehicles</a:t>
+            </a:r>
+            <a:endParaRPr lang="en-US" sz="1100" dirty="0"/>
+          </a:p>
+        </p:txBody>
+      </p:sp>
+      <p:sp>
+        <p:nvSpPr>
+          <p:cNvPr id="18" name="Text 16"/>
+          <p:cNvSpPr/>
+          <p:nvPr/>
+        </p:nvSpPr>
+        <p:spPr>
+          <a:xfrm>
+            <a:off x="6446520" y="2926080"/>
+            <a:ext cx="2468880" cy="1005840"/>
           </a:xfrm>
           <a:prstGeom prst="rect">
             <a:avLst/>
@@ -5160,7 +5304,7 @@
                   <a:srgbClr val="64748B"/>
                 </a:solidFill>
               </a:rPr>
-              <a:t>Unlimited · Multi-tenant · AI + white-label</a:t>
+              <a:t>Full-service · telematics · tax docs · dedicated account team</a:t>
             </a:r>
             <a:endParaRPr lang="en-US" sz="1000" dirty="0"/>
           </a:p>
@@ -5168,13 +5312,13 @@
       </p:sp>
       <p:sp>
         <p:nvSpPr>
-          <p:cNvPr id="16" name="Text 14"/>
-          <p:cNvSpPr/>
-          <p:nvPr/>
-        </p:nvSpPr>
-        <p:spPr>
-          <a:xfrm>
-            <a:off x="548640" y="4114800"/>
+          <p:cNvPr id="19" name="Text 17"/>
+          <p:cNvSpPr/>
+          <p:nvPr/>
+        </p:nvSpPr>
+        <p:spPr>
+          <a:xfrm>
+            <a:off x="548640" y="4434840"/>
             <a:ext cx="8229600" cy="365760"/>
           </a:xfrm>
           <a:prstGeom prst="rect">
@@ -5196,7 +5340,7 @@
                   <a:srgbClr val="0F172A"/>
                 </a:solidFill>
               </a:rPr>
-              <a:t>Next step: Schedule a 30-minute live demo at fleetcomanagement.org</a:t>
+              <a:t>Schedule a free demo: (360) 952-1249  ·  fleetcomanagement.org</a:t>
             </a:r>
             <a:endParaRPr lang="en-US" sz="1300" dirty="0"/>
           </a:p>
@@ -5204,7 +5348,7 @@
       </p:sp>
       <p:sp>
         <p:nvSpPr>
-          <p:cNvPr id="17" name="Text 15"/>
+          <p:cNvPr id="20" name="Text 18"/>
           <p:cNvSpPr/>
           <p:nvPr/>
         </p:nvSpPr>
@@ -5232,7 +5376,7 @@
                   <a:srgbClr val="64748B"/>
                 </a:solidFill>
               </a:rPr>
-              <a:t>Fleetco Management LLC  ·  fleetcomanagement.org  ·  Dallas, TX</a:t>
+              <a:t>Fleetco Management LLC  ·  fleetcomanagement.org  ·  (360) 952-1249  ·  Dallas, TX</a:t>
             </a:r>
             <a:endParaRPr lang="en-US" sz="900" dirty="0"/>
           </a:p>
@@ -5298,7 +5442,7 @@
         </p:nvSpPr>
         <p:spPr>
           <a:xfrm>
-            <a:off x="548640" y="1371600"/>
+            <a:off x="548640" y="1188720"/>
             <a:ext cx="8229600" cy="822960"/>
           </a:xfrm>
           <a:prstGeom prst="rect">
@@ -5334,7 +5478,7 @@
         </p:nvSpPr>
         <p:spPr>
           <a:xfrm>
-            <a:off x="548640" y="2286000"/>
+            <a:off x="548640" y="2011680"/>
             <a:ext cx="8229600" cy="457200"/>
           </a:xfrm>
           <a:prstGeom prst="rect">
@@ -5370,7 +5514,7 @@
         </p:nvSpPr>
         <p:spPr>
           <a:xfrm>
-            <a:off x="548640" y="3200400"/>
+            <a:off x="548640" y="2743200"/>
             <a:ext cx="8229600" cy="457200"/>
           </a:xfrm>
           <a:prstGeom prst="rect">
@@ -5387,14 +5531,14 @@
               <a:buNone/>
             </a:pPr>
             <a:r>
-              <a:rPr lang="en-US" sz="2000" b="1" dirty="0">
+              <a:rPr lang="en-US" sz="2200" b="1" dirty="0">
                 <a:solidFill>
                   <a:srgbClr val="F59E0B"/>
                 </a:solidFill>
               </a:rPr>
               <a:t>fleetcomanagement.org</a:t>
             </a:r>
-            <a:endParaRPr lang="en-US" sz="2000" dirty="0"/>
+            <a:endParaRPr lang="en-US" sz="2200" dirty="0"/>
           </a:p>
         </p:txBody>
       </p:sp>
@@ -5406,7 +5550,7 @@
         </p:nvSpPr>
         <p:spPr>
           <a:xfrm>
-            <a:off x="548640" y="3749040"/>
+            <a:off x="548640" y="3291840"/>
             <a:ext cx="8229600" cy="365760"/>
           </a:xfrm>
           <a:prstGeom prst="rect">
@@ -5428,7 +5572,7 @@
                   <a:srgbClr val="FFFFFF"/>
                 </a:solidFill>
               </a:rPr>
-              <a:t>info@fleetcomanagement.org  ·  (214) 555-0198  ·  Dallas, TX</a:t>
+              <a:t>info@fleetcomanagement.org  ·  (360) 952-1249  ·  Dallas, TX</a:t>
             </a:r>
             <a:endParaRPr lang="en-US" sz="1400" dirty="0"/>
           </a:p>
@@ -5442,7 +5586,7 @@
         </p:nvSpPr>
         <p:spPr>
           <a:xfrm>
-            <a:off x="548640" y="4754880"/>
+            <a:off x="548640" y="4114800"/>
             <a:ext cx="8229600" cy="320040"/>
           </a:xfrm>
           <a:prstGeom prst="rect">
@@ -5459,14 +5603,158 @@
               <a:buNone/>
             </a:pPr>
             <a:r>
-              <a:rPr lang="en-US" sz="1100" dirty="0">
+              <a:rPr lang="en-US" sz="1200" b="1" dirty="0">
+                <a:solidFill>
+                  <a:srgbClr val="FFFFFF"/>
+                </a:solidFill>
+              </a:rPr>
+              <a:t>JaRell D. Slack</a:t>
+            </a:r>
+            <a:endParaRPr lang="en-US" sz="1200" dirty="0"/>
+          </a:p>
+        </p:txBody>
+      </p:sp>
+      <p:sp>
+        <p:nvSpPr>
+          <p:cNvPr id="8" name="Text 6"/>
+          <p:cNvSpPr/>
+          <p:nvPr/>
+        </p:nvSpPr>
+        <p:spPr>
+          <a:xfrm>
+            <a:off x="548640" y="4434840"/>
+            <a:ext cx="8229600" cy="274320"/>
+          </a:xfrm>
+          <a:prstGeom prst="rect">
+            <a:avLst/>
+          </a:prstGeom>
+          <a:noFill/>
+          <a:ln/>
+        </p:spPr>
+        <p:txBody>
+          <a:bodyPr wrap="square" rtlCol="0" anchor="ctr"/>
+          <a:lstStyle/>
+          <a:p>
+            <a:pPr algn="ctr" indent="0" marL="0">
+              <a:buNone/>
+            </a:pPr>
+            <a:r>
+              <a:rPr lang="en-US" sz="1000" dirty="0">
                 <a:solidFill>
                   <a:srgbClr val="64748B"/>
                 </a:solidFill>
               </a:rPr>
-              <a:t>JaRell &amp; Desiree Slack, Owners — Fleetco Management LLC</a:t>
-            </a:r>
-            <a:endParaRPr lang="en-US" sz="1100" dirty="0"/>
+              <a:t>Owner, Director of Fleet Management</a:t>
+            </a:r>
+            <a:endParaRPr lang="en-US" sz="1000" dirty="0"/>
+          </a:p>
+        </p:txBody>
+      </p:sp>
+      <p:sp>
+        <p:nvSpPr>
+          <p:cNvPr id="9" name="Text 7"/>
+          <p:cNvSpPr/>
+          <p:nvPr/>
+        </p:nvSpPr>
+        <p:spPr>
+          <a:xfrm>
+            <a:off x="548640" y="4800600"/>
+            <a:ext cx="8229600" cy="320040"/>
+          </a:xfrm>
+          <a:prstGeom prst="rect">
+            <a:avLst/>
+          </a:prstGeom>
+          <a:noFill/>
+          <a:ln/>
+        </p:spPr>
+        <p:txBody>
+          <a:bodyPr wrap="square" rtlCol="0" anchor="ctr"/>
+          <a:lstStyle/>
+          <a:p>
+            <a:pPr algn="ctr" indent="0" marL="0">
+              <a:buNone/>
+            </a:pPr>
+            <a:r>
+              <a:rPr lang="en-US" sz="1200" b="1" dirty="0">
+                <a:solidFill>
+                  <a:srgbClr val="FFFFFF"/>
+                </a:solidFill>
+              </a:rPr>
+              <a:t>Desiree M. Clark</a:t>
+            </a:r>
+            <a:endParaRPr lang="en-US" sz="1200" dirty="0"/>
+          </a:p>
+        </p:txBody>
+      </p:sp>
+      <p:sp>
+        <p:nvSpPr>
+          <p:cNvPr id="10" name="Text 8"/>
+          <p:cNvSpPr/>
+          <p:nvPr/>
+        </p:nvSpPr>
+        <p:spPr>
+          <a:xfrm>
+            <a:off x="548640" y="5120640"/>
+            <a:ext cx="8229600" cy="274320"/>
+          </a:xfrm>
+          <a:prstGeom prst="rect">
+            <a:avLst/>
+          </a:prstGeom>
+          <a:noFill/>
+          <a:ln/>
+        </p:spPr>
+        <p:txBody>
+          <a:bodyPr wrap="square" rtlCol="0" anchor="ctr"/>
+          <a:lstStyle/>
+          <a:p>
+            <a:pPr algn="ctr" indent="0" marL="0">
+              <a:buNone/>
+            </a:pPr>
+            <a:r>
+              <a:rPr lang="en-US" sz="1000" dirty="0">
+                <a:solidFill>
+                  <a:srgbClr val="64748B"/>
+                </a:solidFill>
+              </a:rPr>
+              <a:t>Co-Owner, Director of Operations</a:t>
+            </a:r>
+            <a:endParaRPr lang="en-US" sz="1000" dirty="0"/>
+          </a:p>
+        </p:txBody>
+      </p:sp>
+      <p:sp>
+        <p:nvSpPr>
+          <p:cNvPr id="11" name="Text 9"/>
+          <p:cNvSpPr/>
+          <p:nvPr/>
+        </p:nvSpPr>
+        <p:spPr>
+          <a:xfrm>
+            <a:off x="548640" y="5577840"/>
+            <a:ext cx="8229600" cy="274320"/>
+          </a:xfrm>
+          <a:prstGeom prst="rect">
+            <a:avLst/>
+          </a:prstGeom>
+          <a:noFill/>
+          <a:ln/>
+        </p:spPr>
+        <p:txBody>
+          <a:bodyPr wrap="square" rtlCol="0" anchor="ctr"/>
+          <a:lstStyle/>
+          <a:p>
+            <a:pPr algn="ctr" indent="0" marL="0">
+              <a:buNone/>
+            </a:pPr>
+            <a:r>
+              <a:rPr lang="en-US" sz="1000" dirty="0">
+                <a:solidFill>
+                  <a:srgbClr val="64748B"/>
+                </a:solidFill>
+              </a:rPr>
+              <a:t>Fleetco Management LLC</a:t>
+            </a:r>
+            <a:endParaRPr lang="en-US" sz="1000" dirty="0"/>
           </a:p>
         </p:txBody>
       </p:sp>

</xml_diff>

<commit_message>
Add owner login, subscription billing, and portal audit fixes.
Owner account seeds on deploy; payment-gated customer provisioning and monthly/yearly pricing are live. Fixes customer data scoping, owner role access across admin tabs, route stop progress, and modal customer dropdowns.

Co-authored-by: Cursor <cursoragent@cursor.com>
</commit_message>
<xml_diff>
--- a/marketing/FleetCo-Client-Presentation.pptx
+++ b/marketing/FleetCo-Client-Presentation.pptx
@@ -5148,11 +5148,11 @@
         <p:spPr>
           <a:xfrm>
             <a:off x="6309360" y="1554480"/>
-            <a:ext cx="2697480" cy="2606040"/>
+            <a:ext cx="2697480" cy="2743200"/>
           </a:xfrm>
           <a:prstGeom prst="roundRect">
             <a:avLst>
-              <a:gd name="adj" fmla="val 2807"/>
+              <a:gd name="adj" fmla="val 2712"/>
             </a:avLst>
           </a:prstGeom>
           <a:solidFill>
@@ -5227,14 +5227,14 @@
               <a:buNone/>
             </a:pPr>
             <a:r>
-              <a:rPr lang="en-US" sz="2000" b="1" dirty="0">
+              <a:rPr lang="en-US" sz="1600" b="1" dirty="0">
                 <a:solidFill>
                   <a:srgbClr val="F59E0B"/>
                 </a:solidFill>
               </a:rPr>
-              <a:t>$999/mo</a:t>
-            </a:r>
-            <a:endParaRPr lang="en-US" sz="2000" dirty="0"/>
+              <a:t>Custom pricing</a:t>
+            </a:r>
+            <a:endParaRPr lang="en-US" sz="1600" dirty="0"/>
           </a:p>
         </p:txBody>
       </p:sp>
@@ -5246,7 +5246,43 @@
         </p:nvSpPr>
         <p:spPr>
           <a:xfrm>
-            <a:off x="6446520" y="2606040"/>
+            <a:off x="6446520" y="2514600"/>
+            <a:ext cx="2468880" cy="228600"/>
+          </a:xfrm>
+          <a:prstGeom prst="rect">
+            <a:avLst/>
+          </a:prstGeom>
+          <a:noFill/>
+          <a:ln/>
+        </p:spPr>
+        <p:txBody>
+          <a:bodyPr wrap="square" rtlCol="0" anchor="ctr"/>
+          <a:lstStyle/>
+          <a:p>
+            <a:pPr indent="0" marL="0">
+              <a:buNone/>
+            </a:pPr>
+            <a:r>
+              <a:rPr lang="en-US" sz="1000" i="1" dirty="0">
+                <a:solidFill>
+                  <a:srgbClr val="64748B"/>
+                </a:solidFill>
+              </a:rPr>
+              <a:t>Quote on request</a:t>
+            </a:r>
+            <a:endParaRPr lang="en-US" sz="1000" dirty="0"/>
+          </a:p>
+        </p:txBody>
+      </p:sp>
+      <p:sp>
+        <p:nvSpPr>
+          <p:cNvPr id="18" name="Text 16"/>
+          <p:cNvSpPr/>
+          <p:nvPr/>
+        </p:nvSpPr>
+        <p:spPr>
+          <a:xfrm>
+            <a:off x="6446520" y="2788920"/>
             <a:ext cx="2468880" cy="274320"/>
           </a:xfrm>
           <a:prstGeom prst="rect">
@@ -5276,13 +5312,13 @@
       </p:sp>
       <p:sp>
         <p:nvSpPr>
-          <p:cNvPr id="18" name="Text 16"/>
-          <p:cNvSpPr/>
-          <p:nvPr/>
-        </p:nvSpPr>
-        <p:spPr>
-          <a:xfrm>
-            <a:off x="6446520" y="2926080"/>
+          <p:cNvPr id="19" name="Text 17"/>
+          <p:cNvSpPr/>
+          <p:nvPr/>
+        </p:nvSpPr>
+        <p:spPr>
+          <a:xfrm>
+            <a:off x="6446520" y="3063240"/>
             <a:ext cx="2468880" cy="1005840"/>
           </a:xfrm>
           <a:prstGeom prst="rect">
@@ -5304,7 +5340,7 @@
                   <a:srgbClr val="64748B"/>
                 </a:solidFill>
               </a:rPr>
-              <a:t>Full-service · telematics · tax docs · dedicated account team</a:t>
+              <a:t>Tailored scope · telematics · custom integrations · dedicated account team</a:t>
             </a:r>
             <a:endParaRPr lang="en-US" sz="1000" dirty="0"/>
           </a:p>
@@ -5312,7 +5348,7 @@
       </p:sp>
       <p:sp>
         <p:nvSpPr>
-          <p:cNvPr id="19" name="Text 17"/>
+          <p:cNvPr id="20" name="Text 18"/>
           <p:cNvSpPr/>
           <p:nvPr/>
         </p:nvSpPr>
@@ -5348,7 +5384,7 @@
       </p:sp>
       <p:sp>
         <p:nvSpPr>
-          <p:cNvPr id="20" name="Text 18"/>
+          <p:cNvPr id="21" name="Text 19"/>
           <p:cNvSpPr/>
           <p:nvPr/>
         </p:nvSpPr>

</xml_diff>

<commit_message>
Expand driver mobile app, load board marketplace, and portal fixes.
Add broker self-registration, load board fee gates, executive marketplace views, driver fuel/work-order pages with offline service worker, and fix inspections page crash.

Co-authored-by: Cursor <cursoragent@cursor.com>
</commit_message>
<xml_diff>
--- a/marketing/FleetCo-Client-Presentation.pptx
+++ b/marketing/FleetCo-Client-Presentation.pptx
@@ -5608,7 +5608,7 @@
                   <a:srgbClr val="FFFFFF"/>
                 </a:solidFill>
               </a:rPr>
-              <a:t>info@fleetcomanagement.org  ·  (360) 952-1249  ·  Dallas, TX</a:t>
+              <a:t>support@fleetcomanagement.org  ·  (360) 952-1249  ·  Dallas, TX</a:t>
             </a:r>
             <a:endParaRPr lang="en-US" sz="1400" dirty="0"/>
           </a:p>
@@ -5644,7 +5644,7 @@
                   <a:srgbClr val="FFFFFF"/>
                 </a:solidFill>
               </a:rPr>
-              <a:t>JaRell D. Slack</a:t>
+              <a:t>Fleetco Management LLC</a:t>
             </a:r>
             <a:endParaRPr lang="en-US" sz="1200" dirty="0"/>
           </a:p>
@@ -5658,7 +5658,7 @@
         </p:nvSpPr>
         <p:spPr>
           <a:xfrm>
-            <a:off x="548640" y="4434840"/>
+            <a:off x="548640" y="4480560"/>
             <a:ext cx="8229600" cy="274320"/>
           </a:xfrm>
           <a:prstGeom prst="rect">
@@ -5680,7 +5680,7 @@
                   <a:srgbClr val="64748B"/>
                 </a:solidFill>
               </a:rPr>
-              <a:t>Owner, Director of Fleet Management</a:t>
+              <a:t>Dallas, TX</a:t>
             </a:r>
             <a:endParaRPr lang="en-US" sz="1000" dirty="0"/>
           </a:p>
@@ -5689,78 +5689,6 @@
       <p:sp>
         <p:nvSpPr>
           <p:cNvPr id="9" name="Text 7"/>
-          <p:cNvSpPr/>
-          <p:nvPr/>
-        </p:nvSpPr>
-        <p:spPr>
-          <a:xfrm>
-            <a:off x="548640" y="4800600"/>
-            <a:ext cx="8229600" cy="320040"/>
-          </a:xfrm>
-          <a:prstGeom prst="rect">
-            <a:avLst/>
-          </a:prstGeom>
-          <a:noFill/>
-          <a:ln/>
-        </p:spPr>
-        <p:txBody>
-          <a:bodyPr wrap="square" rtlCol="0" anchor="ctr"/>
-          <a:lstStyle/>
-          <a:p>
-            <a:pPr algn="ctr" indent="0" marL="0">
-              <a:buNone/>
-            </a:pPr>
-            <a:r>
-              <a:rPr lang="en-US" sz="1200" b="1" dirty="0">
-                <a:solidFill>
-                  <a:srgbClr val="FFFFFF"/>
-                </a:solidFill>
-              </a:rPr>
-              <a:t>Desiree M. Clark</a:t>
-            </a:r>
-            <a:endParaRPr lang="en-US" sz="1200" dirty="0"/>
-          </a:p>
-        </p:txBody>
-      </p:sp>
-      <p:sp>
-        <p:nvSpPr>
-          <p:cNvPr id="10" name="Text 8"/>
-          <p:cNvSpPr/>
-          <p:nvPr/>
-        </p:nvSpPr>
-        <p:spPr>
-          <a:xfrm>
-            <a:off x="548640" y="5120640"/>
-            <a:ext cx="8229600" cy="274320"/>
-          </a:xfrm>
-          <a:prstGeom prst="rect">
-            <a:avLst/>
-          </a:prstGeom>
-          <a:noFill/>
-          <a:ln/>
-        </p:spPr>
-        <p:txBody>
-          <a:bodyPr wrap="square" rtlCol="0" anchor="ctr"/>
-          <a:lstStyle/>
-          <a:p>
-            <a:pPr algn="ctr" indent="0" marL="0">
-              <a:buNone/>
-            </a:pPr>
-            <a:r>
-              <a:rPr lang="en-US" sz="1000" dirty="0">
-                <a:solidFill>
-                  <a:srgbClr val="64748B"/>
-                </a:solidFill>
-              </a:rPr>
-              <a:t>Co-Owner, Director of Operations</a:t>
-            </a:r>
-            <a:endParaRPr lang="en-US" sz="1000" dirty="0"/>
-          </a:p>
-        </p:txBody>
-      </p:sp>
-      <p:sp>
-        <p:nvSpPr>
-          <p:cNvPr id="11" name="Text 9"/>
           <p:cNvSpPr/>
           <p:nvPr/>
         </p:nvSpPr>
@@ -5788,7 +5716,7 @@
                   <a:srgbClr val="64748B"/>
                 </a:solidFill>
               </a:rPr>
-              <a:t>Fleetco Management LLC</a:t>
+              <a:t>FleetCo Management LLC</a:t>
             </a:r>
             <a:endParaRPr lang="en-US" sz="1000" dirty="0"/>
           </a:p>

</xml_diff>